<commit_message>
updates figs, code: micro, genetics and ccby at species level
</commit_message>
<xml_diff>
--- a/figs/sankey arrow.pptx
+++ b/figs/sankey arrow.pptx
@@ -5,8 +5,7 @@
     <p:sldMasterId id="2147483648" r:id="rId1"/>
   </p:sldMasterIdLst>
   <p:sldIdLst>
-    <p:sldId id="256" r:id="rId2"/>
-    <p:sldId id="257" r:id="rId3"/>
+    <p:sldId id="259" r:id="rId2"/>
   </p:sldIdLst>
   <p:sldSz cx="12192000" cy="6858000"/>
   <p:notesSz cx="6858000" cy="9144000"/>
@@ -273,7 +272,7 @@
           <a:p>
             <a:fld id="{5F2E2F26-CF87-4F42-967B-E19DB9147935}" type="datetimeFigureOut">
               <a:rPr lang="pt-PT" smtClean="0"/>
-              <a:t>26/09/25</a:t>
+              <a:t>07/01/26</a:t>
             </a:fld>
             <a:endParaRPr lang="pt-PT"/>
           </a:p>
@@ -473,7 +472,7 @@
           <a:p>
             <a:fld id="{5F2E2F26-CF87-4F42-967B-E19DB9147935}" type="datetimeFigureOut">
               <a:rPr lang="pt-PT" smtClean="0"/>
-              <a:t>26/09/25</a:t>
+              <a:t>07/01/26</a:t>
             </a:fld>
             <a:endParaRPr lang="pt-PT"/>
           </a:p>
@@ -683,7 +682,7 @@
           <a:p>
             <a:fld id="{5F2E2F26-CF87-4F42-967B-E19DB9147935}" type="datetimeFigureOut">
               <a:rPr lang="pt-PT" smtClean="0"/>
-              <a:t>26/09/25</a:t>
+              <a:t>07/01/26</a:t>
             </a:fld>
             <a:endParaRPr lang="pt-PT"/>
           </a:p>
@@ -883,7 +882,7 @@
           <a:p>
             <a:fld id="{5F2E2F26-CF87-4F42-967B-E19DB9147935}" type="datetimeFigureOut">
               <a:rPr lang="pt-PT" smtClean="0"/>
-              <a:t>26/09/25</a:t>
+              <a:t>07/01/26</a:t>
             </a:fld>
             <a:endParaRPr lang="pt-PT"/>
           </a:p>
@@ -1159,7 +1158,7 @@
           <a:p>
             <a:fld id="{5F2E2F26-CF87-4F42-967B-E19DB9147935}" type="datetimeFigureOut">
               <a:rPr lang="pt-PT" smtClean="0"/>
-              <a:t>26/09/25</a:t>
+              <a:t>07/01/26</a:t>
             </a:fld>
             <a:endParaRPr lang="pt-PT"/>
           </a:p>
@@ -1427,7 +1426,7 @@
           <a:p>
             <a:fld id="{5F2E2F26-CF87-4F42-967B-E19DB9147935}" type="datetimeFigureOut">
               <a:rPr lang="pt-PT" smtClean="0"/>
-              <a:t>26/09/25</a:t>
+              <a:t>07/01/26</a:t>
             </a:fld>
             <a:endParaRPr lang="pt-PT"/>
           </a:p>
@@ -1842,7 +1841,7 @@
           <a:p>
             <a:fld id="{5F2E2F26-CF87-4F42-967B-E19DB9147935}" type="datetimeFigureOut">
               <a:rPr lang="pt-PT" smtClean="0"/>
-              <a:t>26/09/25</a:t>
+              <a:t>07/01/26</a:t>
             </a:fld>
             <a:endParaRPr lang="pt-PT"/>
           </a:p>
@@ -1984,7 +1983,7 @@
           <a:p>
             <a:fld id="{5F2E2F26-CF87-4F42-967B-E19DB9147935}" type="datetimeFigureOut">
               <a:rPr lang="pt-PT" smtClean="0"/>
-              <a:t>26/09/25</a:t>
+              <a:t>07/01/26</a:t>
             </a:fld>
             <a:endParaRPr lang="pt-PT"/>
           </a:p>
@@ -2097,7 +2096,7 @@
           <a:p>
             <a:fld id="{5F2E2F26-CF87-4F42-967B-E19DB9147935}" type="datetimeFigureOut">
               <a:rPr lang="pt-PT" smtClean="0"/>
-              <a:t>26/09/25</a:t>
+              <a:t>07/01/26</a:t>
             </a:fld>
             <a:endParaRPr lang="pt-PT"/>
           </a:p>
@@ -2410,7 +2409,7 @@
           <a:p>
             <a:fld id="{5F2E2F26-CF87-4F42-967B-E19DB9147935}" type="datetimeFigureOut">
               <a:rPr lang="pt-PT" smtClean="0"/>
-              <a:t>26/09/25</a:t>
+              <a:t>07/01/26</a:t>
             </a:fld>
             <a:endParaRPr lang="pt-PT"/>
           </a:p>
@@ -2699,7 +2698,7 @@
           <a:p>
             <a:fld id="{5F2E2F26-CF87-4F42-967B-E19DB9147935}" type="datetimeFigureOut">
               <a:rPr lang="pt-PT" smtClean="0"/>
-              <a:t>26/09/25</a:t>
+              <a:t>07/01/26</a:t>
             </a:fld>
             <a:endParaRPr lang="pt-PT"/>
           </a:p>
@@ -2942,7 +2941,7 @@
           <a:p>
             <a:fld id="{5F2E2F26-CF87-4F42-967B-E19DB9147935}" type="datetimeFigureOut">
               <a:rPr lang="pt-PT" smtClean="0"/>
-              <a:t>26/09/25</a:t>
+              <a:t>07/01/26</a:t>
             </a:fld>
             <a:endParaRPr lang="pt-PT"/>
           </a:p>
@@ -3347,7 +3346,13 @@
   <p:cSld>
     <p:spTree>
       <p:nvGrpSpPr>
-        <p:cNvPr id="1" name=""/>
+        <p:cNvPr id="1" name="">
+          <a:extLst>
+            <a:ext uri="{FF2B5EF4-FFF2-40B4-BE49-F238E27FC236}">
+              <a16:creationId xmlns:a16="http://schemas.microsoft.com/office/drawing/2014/main" id="{6811F1EB-2466-5D09-57FE-E61C893937F5}"/>
+            </a:ext>
+          </a:extLst>
+        </p:cNvPr>
         <p:cNvGrpSpPr/>
         <p:nvPr/>
       </p:nvGrpSpPr>
@@ -3359,64 +3364,12 @@
           <a:chExt cx="0" cy="0"/>
         </a:xfrm>
       </p:grpSpPr>
-      <p:sp>
-        <p:nvSpPr>
-          <p:cNvPr id="8" name="Rectangle 7">
-            <a:extLst>
-              <a:ext uri="{FF2B5EF4-FFF2-40B4-BE49-F238E27FC236}">
-                <a16:creationId xmlns:a16="http://schemas.microsoft.com/office/drawing/2014/main" id="{9B17DE52-623A-AFBD-8EED-44289D9E193C}"/>
-              </a:ext>
-            </a:extLst>
-          </p:cNvPr>
-          <p:cNvSpPr/>
-          <p:nvPr/>
-        </p:nvSpPr>
-        <p:spPr>
-          <a:xfrm>
-            <a:off x="0" y="128081"/>
-            <a:ext cx="12192000" cy="7262038"/>
-          </a:xfrm>
-          <a:prstGeom prst="rect">
-            <a:avLst/>
-          </a:prstGeom>
-          <a:solidFill>
-            <a:schemeClr val="bg1"/>
-          </a:solidFill>
-          <a:ln>
-            <a:noFill/>
-          </a:ln>
-        </p:spPr>
-        <p:style>
-          <a:lnRef idx="2">
-            <a:schemeClr val="accent1">
-              <a:shade val="15000"/>
-            </a:schemeClr>
-          </a:lnRef>
-          <a:fillRef idx="1">
-            <a:schemeClr val="accent1"/>
-          </a:fillRef>
-          <a:effectRef idx="0">
-            <a:schemeClr val="accent1"/>
-          </a:effectRef>
-          <a:fontRef idx="minor">
-            <a:schemeClr val="lt1"/>
-          </a:fontRef>
-        </p:style>
-        <p:txBody>
-          <a:bodyPr rtlCol="0" anchor="ctr"/>
-          <a:lstStyle/>
-          <a:p>
-            <a:pPr algn="ctr"/>
-            <a:endParaRPr lang="pt-PT"/>
-          </a:p>
-        </p:txBody>
-      </p:sp>
       <p:grpSp>
         <p:nvGrpSpPr>
-          <p:cNvPr id="4" name="Group 3">
-            <a:extLst>
-              <a:ext uri="{FF2B5EF4-FFF2-40B4-BE49-F238E27FC236}">
-                <a16:creationId xmlns:a16="http://schemas.microsoft.com/office/drawing/2014/main" id="{FA6A3CBD-D628-8531-9439-6DFFD3B4771C}"/>
+          <p:cNvPr id="10" name="Group 9">
+            <a:extLst>
+              <a:ext uri="{FF2B5EF4-FFF2-40B4-BE49-F238E27FC236}">
+                <a16:creationId xmlns:a16="http://schemas.microsoft.com/office/drawing/2014/main" id="{4AA19B40-1FD4-983C-6E9C-7CBEB219DE52}"/>
               </a:ext>
             </a:extLst>
           </p:cNvPr>
@@ -3425,18 +3378,70 @@
         </p:nvGrpSpPr>
         <p:grpSpPr>
           <a:xfrm>
-            <a:off x="323901" y="443891"/>
-            <a:ext cx="11544199" cy="6630419"/>
-            <a:chOff x="423161" y="99500"/>
-            <a:chExt cx="11544199" cy="6630419"/>
+            <a:off x="-241228" y="-92969"/>
+            <a:ext cx="12585454" cy="7262038"/>
+            <a:chOff x="-241228" y="258711"/>
+            <a:chExt cx="12585454" cy="7262038"/>
           </a:xfrm>
         </p:grpSpPr>
+        <p:sp>
+          <p:nvSpPr>
+            <p:cNvPr id="8" name="Rectangle 7">
+              <a:extLst>
+                <a:ext uri="{FF2B5EF4-FFF2-40B4-BE49-F238E27FC236}">
+                  <a16:creationId xmlns:a16="http://schemas.microsoft.com/office/drawing/2014/main" id="{BC311307-62C3-98AC-85B4-AF6357089962}"/>
+                </a:ext>
+              </a:extLst>
+            </p:cNvPr>
+            <p:cNvSpPr/>
+            <p:nvPr/>
+          </p:nvSpPr>
+          <p:spPr>
+            <a:xfrm>
+              <a:off x="-140677" y="258711"/>
+              <a:ext cx="12192000" cy="7262038"/>
+            </a:xfrm>
+            <a:prstGeom prst="rect">
+              <a:avLst/>
+            </a:prstGeom>
+            <a:solidFill>
+              <a:schemeClr val="bg1"/>
+            </a:solidFill>
+            <a:ln>
+              <a:noFill/>
+            </a:ln>
+          </p:spPr>
+          <p:style>
+            <a:lnRef idx="2">
+              <a:schemeClr val="accent1">
+                <a:shade val="15000"/>
+              </a:schemeClr>
+            </a:lnRef>
+            <a:fillRef idx="1">
+              <a:schemeClr val="accent1"/>
+            </a:fillRef>
+            <a:effectRef idx="0">
+              <a:schemeClr val="accent1"/>
+            </a:effectRef>
+            <a:fontRef idx="minor">
+              <a:schemeClr val="lt1"/>
+            </a:fontRef>
+          </p:style>
+          <p:txBody>
+            <a:bodyPr rtlCol="0" anchor="ctr"/>
+            <a:lstStyle/>
+            <a:p>
+              <a:pPr algn="ctr"/>
+              <a:endParaRPr lang="pt-PT"/>
+            </a:p>
+          </p:txBody>
+        </p:sp>
         <p:grpSp>
           <p:nvGrpSpPr>
             <p:cNvPr id="9" name="Group 8">
               <a:extLst>
                 <a:ext uri="{FF2B5EF4-FFF2-40B4-BE49-F238E27FC236}">
-                  <a16:creationId xmlns:a16="http://schemas.microsoft.com/office/drawing/2014/main" id="{C1765075-76B2-06B9-BBBD-4978F55C8AFD}"/>
+                  <a16:creationId xmlns:a16="http://schemas.microsoft.com/office/drawing/2014/main" id="{6602BEF3-ECFA-0B05-D399-7A3FA0C71FD1}"/>
                 </a:ext>
               </a:extLst>
             </p:cNvPr>
@@ -3445,10 +3450,10 @@
           </p:nvGrpSpPr>
           <p:grpSpPr>
             <a:xfrm>
-              <a:off x="423161" y="99500"/>
-              <a:ext cx="10316004" cy="6630419"/>
-              <a:chOff x="582656" y="99500"/>
-              <a:chExt cx="10316004" cy="6630419"/>
+              <a:off x="-241228" y="360436"/>
+              <a:ext cx="11368206" cy="6840488"/>
+              <a:chOff x="572388" y="422341"/>
+              <a:chExt cx="10390832" cy="6127078"/>
             </a:xfrm>
           </p:grpSpPr>
           <p:pic>
@@ -3456,7 +3461,7 @@
               <p:cNvPr id="5" name="Picture 4">
                 <a:extLst>
                   <a:ext uri="{FF2B5EF4-FFF2-40B4-BE49-F238E27FC236}">
-                    <a16:creationId xmlns:a16="http://schemas.microsoft.com/office/drawing/2014/main" id="{745D2EA7-5B8E-9243-2B90-CDAA2AF403ED}"/>
+                    <a16:creationId xmlns:a16="http://schemas.microsoft.com/office/drawing/2014/main" id="{F6D33A5A-DB48-EE3D-C34D-47F5AD21E5EA}"/>
                   </a:ext>
                 </a:extLst>
               </p:cNvPr>
@@ -3467,14 +3472,13 @@
             </p:nvPicPr>
             <p:blipFill>
               <a:blip r:embed="rId2"/>
-              <a:stretch>
-                <a:fillRect/>
-              </a:stretch>
+              <a:srcRect/>
+              <a:stretch/>
             </p:blipFill>
             <p:spPr>
               <a:xfrm>
-                <a:off x="582656" y="574632"/>
-                <a:ext cx="10316004" cy="6155287"/>
+                <a:off x="572388" y="1011281"/>
+                <a:ext cx="10390832" cy="5538138"/>
               </a:xfrm>
               <a:prstGeom prst="rect">
                 <a:avLst/>
@@ -3486,7 +3490,7 @@
               <p:cNvPr id="6" name="TextBox 5">
                 <a:extLst>
                   <a:ext uri="{FF2B5EF4-FFF2-40B4-BE49-F238E27FC236}">
-                    <a16:creationId xmlns:a16="http://schemas.microsoft.com/office/drawing/2014/main" id="{95367EFC-2594-9B5F-DADC-98673C95C6CD}"/>
+                    <a16:creationId xmlns:a16="http://schemas.microsoft.com/office/drawing/2014/main" id="{5BE98D50-DF26-8809-CC59-8A60B4BBF1EA}"/>
                   </a:ext>
                 </a:extLst>
               </p:cNvPr>
@@ -3495,8 +3499,8 @@
             </p:nvSpPr>
             <p:spPr>
               <a:xfrm>
-                <a:off x="8720228" y="99500"/>
-                <a:ext cx="1325730" cy="415498"/>
+                <a:off x="7906785" y="422341"/>
+                <a:ext cx="1183631" cy="358381"/>
               </a:xfrm>
               <a:prstGeom prst="rect">
                 <a:avLst/>
@@ -3511,12 +3515,12 @@
               <a:p>
                 <a:pPr algn="ctr"/>
                 <a:r>
-                  <a:rPr lang="pt-PT" sz="2100" dirty="0" err="1">
+                  <a:rPr lang="pt-PT" sz="2000" dirty="0" err="1">
                     <a:latin typeface="Helvetica" pitchFamily="2" charset="0"/>
                   </a:rPr>
                   <a:t>modelling</a:t>
                 </a:r>
-                <a:endParaRPr lang="pt-PT" sz="2100" dirty="0">
+                <a:endParaRPr lang="pt-PT" sz="2000" dirty="0">
                   <a:latin typeface="Helvetica" pitchFamily="2" charset="0"/>
                 </a:endParaRPr>
               </a:p>
@@ -3527,7 +3531,7 @@
               <p:cNvPr id="7" name="Right Arrow 6">
                 <a:extLst>
                   <a:ext uri="{FF2B5EF4-FFF2-40B4-BE49-F238E27FC236}">
-                    <a16:creationId xmlns:a16="http://schemas.microsoft.com/office/drawing/2014/main" id="{FB578E16-09F0-825E-2534-62D49A23F457}"/>
+                    <a16:creationId xmlns:a16="http://schemas.microsoft.com/office/drawing/2014/main" id="{A0BD99BE-D77E-F619-681F-78DA9588C5AB}"/>
                   </a:ext>
                 </a:extLst>
               </p:cNvPr>
@@ -3536,8 +3540,8 @@
             </p:nvSpPr>
             <p:spPr>
               <a:xfrm>
-                <a:off x="8806149" y="534876"/>
-                <a:ext cx="1219200" cy="302406"/>
+                <a:off x="7990125" y="848436"/>
+                <a:ext cx="1088519" cy="302406"/>
               </a:xfrm>
               <a:prstGeom prst="rightArrow">
                 <a:avLst>
@@ -3581,7 +3585,7 @@
             <p:cNvPr id="2" name="TextBox 1">
               <a:extLst>
                 <a:ext uri="{FF2B5EF4-FFF2-40B4-BE49-F238E27FC236}">
-                  <a16:creationId xmlns:a16="http://schemas.microsoft.com/office/drawing/2014/main" id="{E320709B-6627-F77A-D93B-99BABFFF7B4F}"/>
+                  <a16:creationId xmlns:a16="http://schemas.microsoft.com/office/drawing/2014/main" id="{20E35D41-2FDF-14F9-AD73-E0DD2012E0AB}"/>
                 </a:ext>
               </a:extLst>
             </p:cNvPr>
@@ -3590,7 +3594,7 @@
           </p:nvSpPr>
           <p:spPr>
             <a:xfrm>
-              <a:off x="10468177" y="1573312"/>
+              <a:off x="10946810" y="1810683"/>
               <a:ext cx="1360959" cy="353943"/>
             </a:xfrm>
             <a:prstGeom prst="rect">
@@ -3608,7 +3612,7 @@
                 <a:rPr lang="pt-PT" sz="1700" dirty="0">
                   <a:latin typeface="Helvetica" pitchFamily="2" charset="0"/>
                 </a:rPr>
-                <a:t>n = 998054</a:t>
+                <a:t>n = 718431</a:t>
               </a:r>
             </a:p>
           </p:txBody>
@@ -3618,7 +3622,7 @@
             <p:cNvPr id="3" name="TextBox 2">
               <a:extLst>
                 <a:ext uri="{FF2B5EF4-FFF2-40B4-BE49-F238E27FC236}">
-                  <a16:creationId xmlns:a16="http://schemas.microsoft.com/office/drawing/2014/main" id="{C848402B-7381-A8B5-9CA7-74BEADBC7807}"/>
+                  <a16:creationId xmlns:a16="http://schemas.microsoft.com/office/drawing/2014/main" id="{73C3BA7D-C236-9931-B35C-521D3089B0E9}"/>
                 </a:ext>
               </a:extLst>
             </p:cNvPr>
@@ -3627,7 +3631,7 @@
           </p:nvSpPr>
           <p:spPr>
             <a:xfrm>
-              <a:off x="10468177" y="4519757"/>
+              <a:off x="10845043" y="4931259"/>
               <a:ext cx="1499183" cy="353943"/>
             </a:xfrm>
             <a:prstGeom prst="rect">
@@ -3645,7 +3649,7 @@
                 <a:rPr lang="pt-PT" sz="1700" dirty="0">
                   <a:latin typeface="Helvetica" pitchFamily="2" charset="0"/>
                 </a:rPr>
-                <a:t>n = 1511334</a:t>
+                <a:t>n = 1790957</a:t>
               </a:r>
             </a:p>
           </p:txBody>
@@ -3654,91 +3658,7 @@
     </p:spTree>
     <p:extLst>
       <p:ext uri="{BB962C8B-B14F-4D97-AF65-F5344CB8AC3E}">
-        <p14:creationId xmlns:p14="http://schemas.microsoft.com/office/powerpoint/2010/main" val="2877939978"/>
-      </p:ext>
-    </p:extLst>
-  </p:cSld>
-  <p:clrMapOvr>
-    <a:masterClrMapping/>
-  </p:clrMapOvr>
-</p:sld>
-</file>
-
-<file path=ppt/slides/slide2.xml><?xml version="1.0" encoding="utf-8"?>
-<p:sld xmlns:a="http://schemas.openxmlformats.org/drawingml/2006/main" xmlns:r="http://schemas.openxmlformats.org/officeDocument/2006/relationships" xmlns:p="http://schemas.openxmlformats.org/presentationml/2006/main">
-  <p:cSld>
-    <p:spTree>
-      <p:nvGrpSpPr>
-        <p:cNvPr id="1" name=""/>
-        <p:cNvGrpSpPr/>
-        <p:nvPr/>
-      </p:nvGrpSpPr>
-      <p:grpSpPr>
-        <a:xfrm>
-          <a:off x="0" y="0"/>
-          <a:ext cx="0" cy="0"/>
-          <a:chOff x="0" y="0"/>
-          <a:chExt cx="0" cy="0"/>
-        </a:xfrm>
-      </p:grpSpPr>
-      <p:sp>
-        <p:nvSpPr>
-          <p:cNvPr id="2" name="Title 1">
-            <a:extLst>
-              <a:ext uri="{FF2B5EF4-FFF2-40B4-BE49-F238E27FC236}">
-                <a16:creationId xmlns:a16="http://schemas.microsoft.com/office/drawing/2014/main" id="{CDC2A6D4-14AE-9984-D4F0-D137EA3455F3}"/>
-              </a:ext>
-            </a:extLst>
-          </p:cNvPr>
-          <p:cNvSpPr>
-            <a:spLocks noGrp="1"/>
-          </p:cNvSpPr>
-          <p:nvPr>
-            <p:ph type="title"/>
-          </p:nvPr>
-        </p:nvSpPr>
-        <p:spPr/>
-        <p:txBody>
-          <a:bodyPr/>
-          <a:lstStyle/>
-          <a:p>
-            <a:endParaRPr lang="pt-PT"/>
-          </a:p>
-        </p:txBody>
-      </p:sp>
-      <p:pic>
-        <p:nvPicPr>
-          <p:cNvPr id="5" name="Content Placeholder 4">
-            <a:extLst>
-              <a:ext uri="{FF2B5EF4-FFF2-40B4-BE49-F238E27FC236}">
-                <a16:creationId xmlns:a16="http://schemas.microsoft.com/office/drawing/2014/main" id="{072AB7BF-790F-DA5E-AA9F-023EDEA1B37C}"/>
-              </a:ext>
-            </a:extLst>
-          </p:cNvPr>
-          <p:cNvPicPr>
-            <a:picLocks noGrp="1" noChangeAspect="1"/>
-          </p:cNvPicPr>
-          <p:nvPr>
-            <p:ph idx="1"/>
-          </p:nvPr>
-        </p:nvPicPr>
-        <p:blipFill>
-          <a:blip r:embed="rId2"/>
-          <a:stretch>
-            <a:fillRect/>
-          </a:stretch>
-        </p:blipFill>
-        <p:spPr>
-          <a:xfrm>
-            <a:off x="3041650" y="2178844"/>
-            <a:ext cx="6108700" cy="3644900"/>
-          </a:xfrm>
-        </p:spPr>
-      </p:pic>
-    </p:spTree>
-    <p:extLst>
-      <p:ext uri="{BB962C8B-B14F-4D97-AF65-F5344CB8AC3E}">
-        <p14:creationId xmlns:p14="http://schemas.microsoft.com/office/powerpoint/2010/main" val="2716708017"/>
+        <p14:creationId xmlns:p14="http://schemas.microsoft.com/office/powerpoint/2010/main" val="268361254"/>
       </p:ext>
     </p:extLst>
   </p:cSld>

</xml_diff>